<commit_message>
+ improved figures for QB accuracy
</commit_message>
<xml_diff>
--- a/YET_CEHR.pptx
+++ b/YET_CEHR.pptx
@@ -280,7 +280,7 @@
           </a:lstStyle>
           <a:p>
             <a:fld id="{34E8673A-D099-4C54-8869-3117A1A492A2}" type="datetimeFigureOut">
-              <a:t>9/15/2025</a:t>
+              <a:t>11/19/2025</a:t>
             </a:fld>
             <a:endParaRPr lang="en-US"/>
           </a:p>
@@ -2189,7 +2189,7 @@
           <a:p>
             <a:fld id="{710AE426-CBD1-49BA-A1DA-945CCEE2ED80}" type="datetimeFigureOut">
               <a:rPr lang="en-US" smtClean="0"/>
-              <a:t>9/15/2025</a:t>
+              <a:t>11/19/2025</a:t>
             </a:fld>
             <a:endParaRPr lang="en-US"/>
           </a:p>
@@ -2378,7 +2378,7 @@
           <a:p>
             <a:fld id="{710AE426-CBD1-49BA-A1DA-945CCEE2ED80}" type="datetimeFigureOut">
               <a:rPr lang="en-US" smtClean="0"/>
-              <a:t>9/15/2025</a:t>
+              <a:t>11/19/2025</a:t>
             </a:fld>
             <a:endParaRPr lang="en-US"/>
           </a:p>
@@ -2642,7 +2642,7 @@
           <a:p>
             <a:fld id="{710AE426-CBD1-49BA-A1DA-945CCEE2ED80}" type="datetimeFigureOut">
               <a:rPr lang="en-US" smtClean="0"/>
-              <a:t>9/15/2025</a:t>
+              <a:t>11/19/2025</a:t>
             </a:fld>
             <a:endParaRPr lang="en-US"/>
           </a:p>
@@ -2990,7 +2990,7 @@
           <a:p>
             <a:fld id="{710AE426-CBD1-49BA-A1DA-945CCEE2ED80}" type="datetimeFigureOut">
               <a:rPr lang="en-US" smtClean="0"/>
-              <a:t>9/15/2025</a:t>
+              <a:t>11/19/2025</a:t>
             </a:fld>
             <a:endParaRPr lang="en-US"/>
           </a:p>
@@ -3232,7 +3232,7 @@
           <a:p>
             <a:fld id="{710AE426-CBD1-49BA-A1DA-945CCEE2ED80}" type="datetimeFigureOut">
               <a:rPr lang="en-US" smtClean="0"/>
-              <a:t>9/15/2025</a:t>
+              <a:t>11/19/2025</a:t>
             </a:fld>
             <a:endParaRPr lang="en-US"/>
           </a:p>
@@ -3449,7 +3449,7 @@
           <a:p>
             <a:fld id="{710AE426-CBD1-49BA-A1DA-945CCEE2ED80}" type="datetimeFigureOut">
               <a:rPr lang="en-US" smtClean="0"/>
-              <a:t>9/15/2025</a:t>
+              <a:t>11/19/2025</a:t>
             </a:fld>
             <a:endParaRPr lang="en-US"/>
           </a:p>
@@ -3666,7 +3666,7 @@
           <a:p>
             <a:fld id="{710AE426-CBD1-49BA-A1DA-945CCEE2ED80}" type="datetimeFigureOut">
               <a:rPr lang="en-US" smtClean="0"/>
-              <a:t>9/15/2025</a:t>
+              <a:t>11/19/2025</a:t>
             </a:fld>
             <a:endParaRPr lang="en-US"/>
           </a:p>
@@ -3883,7 +3883,7 @@
           <a:p>
             <a:fld id="{710AE426-CBD1-49BA-A1DA-945CCEE2ED80}" type="datetimeFigureOut">
               <a:rPr lang="en-US" smtClean="0"/>
-              <a:t>9/15/2025</a:t>
+              <a:t>11/19/2025</a:t>
             </a:fld>
             <a:endParaRPr lang="en-US"/>
           </a:p>
@@ -4100,7 +4100,7 @@
           <a:p>
             <a:fld id="{710AE426-CBD1-49BA-A1DA-945CCEE2ED80}" type="datetimeFigureOut">
               <a:rPr lang="en-US" smtClean="0"/>
-              <a:t>9/15/2025</a:t>
+              <a:t>11/19/2025</a:t>
             </a:fld>
             <a:endParaRPr lang="en-US"/>
           </a:p>
@@ -4422,7 +4422,7 @@
           <a:p>
             <a:fld id="{710AE426-CBD1-49BA-A1DA-945CCEE2ED80}" type="datetimeFigureOut">
               <a:rPr lang="en-US" smtClean="0"/>
-              <a:t>9/15/2025</a:t>
+              <a:t>11/19/2025</a:t>
             </a:fld>
             <a:endParaRPr lang="en-US"/>
           </a:p>
@@ -4654,7 +4654,7 @@
           <a:p>
             <a:fld id="{710AE426-CBD1-49BA-A1DA-945CCEE2ED80}" type="datetimeFigureOut">
               <a:rPr lang="en-US" smtClean="0"/>
-              <a:t>9/15/2025</a:t>
+              <a:t>11/19/2025</a:t>
             </a:fld>
             <a:endParaRPr lang="en-US"/>
           </a:p>
@@ -4918,7 +4918,7 @@
           <a:p>
             <a:fld id="{710AE426-CBD1-49BA-A1DA-945CCEE2ED80}" type="datetimeFigureOut">
               <a:rPr lang="en-US" smtClean="0"/>
-              <a:t>9/15/2025</a:t>
+              <a:t>11/19/2025</a:t>
             </a:fld>
             <a:endParaRPr lang="en-US"/>
           </a:p>
@@ -5192,7 +5192,7 @@
           <a:p>
             <a:fld id="{710AE426-CBD1-49BA-A1DA-945CCEE2ED80}" type="datetimeFigureOut">
               <a:rPr lang="en-US" smtClean="0"/>
-              <a:t>9/15/2025</a:t>
+              <a:t>11/19/2025</a:t>
             </a:fld>
             <a:endParaRPr lang="en-US"/>
           </a:p>
@@ -5424,7 +5424,7 @@
           <a:p>
             <a:fld id="{710AE426-CBD1-49BA-A1DA-945CCEE2ED80}" type="datetimeFigureOut">
               <a:rPr lang="en-US" smtClean="0"/>
-              <a:t>9/15/2025</a:t>
+              <a:t>11/19/2025</a:t>
             </a:fld>
             <a:endParaRPr lang="en-US"/>
           </a:p>
@@ -5759,7 +5759,7 @@
           <a:p>
             <a:fld id="{710AE426-CBD1-49BA-A1DA-945CCEE2ED80}" type="datetimeFigureOut">
               <a:rPr lang="en-US" smtClean="0"/>
-              <a:t>9/15/2025</a:t>
+              <a:t>11/19/2025</a:t>
             </a:fld>
             <a:endParaRPr lang="en-US"/>
           </a:p>
@@ -6000,7 +6000,7 @@
           <a:p>
             <a:fld id="{710AE426-CBD1-49BA-A1DA-945CCEE2ED80}" type="datetimeFigureOut">
               <a:rPr lang="en-US" smtClean="0"/>
-              <a:t>9/15/2025</a:t>
+              <a:t>11/19/2025</a:t>
             </a:fld>
             <a:endParaRPr lang="en-US"/>
           </a:p>
@@ -6335,7 +6335,7 @@
           <a:p>
             <a:fld id="{710AE426-CBD1-49BA-A1DA-945CCEE2ED80}" type="datetimeFigureOut">
               <a:rPr lang="en-US" smtClean="0"/>
-              <a:t>9/15/2025</a:t>
+              <a:t>11/19/2025</a:t>
             </a:fld>
             <a:endParaRPr lang="en-US"/>
           </a:p>
@@ -6567,7 +6567,7 @@
           <a:p>
             <a:fld id="{710AE426-CBD1-49BA-A1DA-945CCEE2ED80}" type="datetimeFigureOut">
               <a:rPr lang="en-US" smtClean="0"/>
-              <a:t>9/15/2025</a:t>
+              <a:t>11/19/2025</a:t>
             </a:fld>
             <a:endParaRPr lang="en-US"/>
           </a:p>
@@ -6973,7 +6973,7 @@
           <a:p>
             <a:fld id="{710AE426-CBD1-49BA-A1DA-945CCEE2ED80}" type="datetimeFigureOut">
               <a:rPr lang="en-US" smtClean="0"/>
-              <a:t>9/15/2025</a:t>
+              <a:t>11/19/2025</a:t>
             </a:fld>
             <a:endParaRPr lang="en-US"/>
           </a:p>
@@ -7237,7 +7237,7 @@
           <a:p>
             <a:fld id="{710AE426-CBD1-49BA-A1DA-945CCEE2ED80}" type="datetimeFigureOut">
               <a:rPr lang="en-US" smtClean="0"/>
-              <a:t>9/15/2025</a:t>
+              <a:t>11/19/2025</a:t>
             </a:fld>
             <a:endParaRPr lang="en-US"/>
           </a:p>
@@ -7624,7 +7624,7 @@
           <a:p>
             <a:fld id="{710AE426-CBD1-49BA-A1DA-945CCEE2ED80}" type="datetimeFigureOut">
               <a:rPr lang="en-US" smtClean="0"/>
-              <a:t>9/15/2025</a:t>
+              <a:t>11/19/2025</a:t>
             </a:fld>
             <a:endParaRPr lang="en-US"/>
           </a:p>
@@ -7911,7 +7911,7 @@
           <a:p>
             <a:fld id="{710AE426-CBD1-49BA-A1DA-945CCEE2ED80}" type="datetimeFigureOut">
               <a:rPr lang="en-US" smtClean="0"/>
-              <a:t>9/15/2025</a:t>
+              <a:t>11/19/2025</a:t>
             </a:fld>
             <a:endParaRPr lang="en-US"/>
           </a:p>
@@ -8221,7 +8221,7 @@
           <a:p>
             <a:fld id="{710AE426-CBD1-49BA-A1DA-945CCEE2ED80}" type="datetimeFigureOut">
               <a:rPr lang="en-US" smtClean="0"/>
-              <a:t>9/15/2025</a:t>
+              <a:t>11/19/2025</a:t>
             </a:fld>
             <a:endParaRPr lang="en-US"/>
           </a:p>
@@ -8524,7 +8524,7 @@
           <a:p>
             <a:fld id="{710AE426-CBD1-49BA-A1DA-945CCEE2ED80}" type="datetimeFigureOut">
               <a:rPr lang="en-US" smtClean="0"/>
-              <a:t>9/15/2025</a:t>
+              <a:t>11/19/2025</a:t>
             </a:fld>
             <a:endParaRPr lang="en-US"/>
           </a:p>
@@ -8774,7 +8774,7 @@
           <a:p>
             <a:fld id="{710AE426-CBD1-49BA-A1DA-945CCEE2ED80}" type="datetimeFigureOut">
               <a:rPr lang="en-US" smtClean="0"/>
-              <a:t>9/15/2025</a:t>
+              <a:t>11/19/2025</a:t>
             </a:fld>
             <a:endParaRPr lang="en-US"/>
           </a:p>
@@ -9106,7 +9106,7 @@
           <a:p>
             <a:fld id="{710AE426-CBD1-49BA-A1DA-945CCEE2ED80}" type="datetimeFigureOut">
               <a:rPr lang="en-US" smtClean="0"/>
-              <a:t>9/15/2025</a:t>
+              <a:t>11/19/2025</a:t>
             </a:fld>
             <a:endParaRPr lang="en-US"/>
           </a:p>
@@ -9431,7 +9431,7 @@
           <a:p>
             <a:fld id="{710AE426-CBD1-49BA-A1DA-945CCEE2ED80}" type="datetimeFigureOut">
               <a:rPr lang="en-US" smtClean="0"/>
-              <a:t>9/15/2025</a:t>
+              <a:t>11/19/2025</a:t>
             </a:fld>
             <a:endParaRPr lang="en-US"/>
           </a:p>
@@ -9709,7 +9709,7 @@
           <a:p>
             <a:fld id="{710AE426-CBD1-49BA-A1DA-945CCEE2ED80}" type="datetimeFigureOut">
               <a:rPr lang="en-US" smtClean="0"/>
-              <a:t>9/15/2025</a:t>
+              <a:t>11/19/2025</a:t>
             </a:fld>
             <a:endParaRPr lang="en-US"/>
           </a:p>
@@ -9978,7 +9978,7 @@
           <a:p>
             <a:fld id="{710AE426-CBD1-49BA-A1DA-945CCEE2ED80}" type="datetimeFigureOut">
               <a:rPr lang="en-US" smtClean="0"/>
-              <a:t>9/15/2025</a:t>
+              <a:t>11/19/2025</a:t>
             </a:fld>
             <a:endParaRPr lang="en-US"/>
           </a:p>
@@ -10242,7 +10242,7 @@
           <a:p>
             <a:fld id="{710AE426-CBD1-49BA-A1DA-945CCEE2ED80}" type="datetimeFigureOut">
               <a:rPr lang="en-US" smtClean="0"/>
-              <a:t>9/15/2025</a:t>
+              <a:t>11/19/2025</a:t>
             </a:fld>
             <a:endParaRPr lang="en-US"/>
           </a:p>
@@ -10473,7 +10473,7 @@
           <a:p>
             <a:fld id="{710AE426-CBD1-49BA-A1DA-945CCEE2ED80}" type="datetimeFigureOut">
               <a:rPr lang="en-US" smtClean="0"/>
-              <a:t>9/15/2025</a:t>
+              <a:t>11/19/2025</a:t>
             </a:fld>
             <a:endParaRPr lang="en-US"/>
           </a:p>
@@ -10707,7 +10707,7 @@
           <a:p>
             <a:fld id="{710AE426-CBD1-49BA-A1DA-945CCEE2ED80}" type="datetimeFigureOut">
               <a:rPr lang="en-US" smtClean="0"/>
-              <a:t>9/15/2025</a:t>
+              <a:t>11/19/2025</a:t>
             </a:fld>
             <a:endParaRPr lang="en-US"/>
           </a:p>
@@ -10929,7 +10929,7 @@
           <a:p>
             <a:fld id="{710AE426-CBD1-49BA-A1DA-945CCEE2ED80}" type="datetimeFigureOut">
               <a:rPr lang="en-US" smtClean="0"/>
-              <a:t>9/15/2025</a:t>
+              <a:t>11/19/2025</a:t>
             </a:fld>
             <a:endParaRPr lang="en-US"/>
           </a:p>
@@ -11239,7 +11239,7 @@
           <a:p>
             <a:fld id="{710AE426-CBD1-49BA-A1DA-945CCEE2ED80}" type="datetimeFigureOut">
               <a:rPr lang="en-US" smtClean="0"/>
-              <a:t>9/15/2025</a:t>
+              <a:t>11/19/2025</a:t>
             </a:fld>
             <a:endParaRPr lang="en-US"/>
           </a:p>
@@ -11455,7 +11455,7 @@
           <a:p>
             <a:fld id="{710AE426-CBD1-49BA-A1DA-945CCEE2ED80}" type="datetimeFigureOut">
               <a:rPr lang="en-US" smtClean="0"/>
-              <a:t>9/15/2025</a:t>
+              <a:t>11/19/2025</a:t>
             </a:fld>
             <a:endParaRPr lang="en-US"/>
           </a:p>
@@ -11732,7 +11732,7 @@
           <a:p>
             <a:fld id="{710AE426-CBD1-49BA-A1DA-945CCEE2ED80}" type="datetimeFigureOut">
               <a:rPr lang="en-US" smtClean="0"/>
-              <a:t>9/15/2025</a:t>
+              <a:t>11/19/2025</a:t>
             </a:fld>
             <a:endParaRPr lang="en-US"/>
           </a:p>
@@ -11979,7 +11979,7 @@
           <a:p>
             <a:fld id="{710AE426-CBD1-49BA-A1DA-945CCEE2ED80}" type="datetimeFigureOut">
               <a:rPr lang="en-US" smtClean="0"/>
-              <a:t>9/15/2025</a:t>
+              <a:t>11/19/2025</a:t>
             </a:fld>
             <a:endParaRPr lang="en-US"/>
           </a:p>
@@ -12136,7 +12136,7 @@
           <a:p>
             <a:fld id="{710AE426-CBD1-49BA-A1DA-945CCEE2ED80}" type="datetimeFigureOut">
               <a:rPr lang="en-US" smtClean="0"/>
-              <a:t>9/15/2025</a:t>
+              <a:t>11/19/2025</a:t>
             </a:fld>
             <a:endParaRPr lang="en-US"/>
           </a:p>
@@ -12518,7 +12518,7 @@
           <a:p>
             <a:fld id="{710AE426-CBD1-49BA-A1DA-945CCEE2ED80}" type="datetimeFigureOut">
               <a:rPr lang="en-US" smtClean="0"/>
-              <a:t>9/15/2025</a:t>
+              <a:t>11/19/2025</a:t>
             </a:fld>
             <a:endParaRPr lang="en-US"/>
           </a:p>
@@ -12650,7 +12650,7 @@
           <a:p>
             <a:fld id="{710AE426-CBD1-49BA-A1DA-945CCEE2ED80}" type="datetimeFigureOut">
               <a:rPr lang="en-US" smtClean="0"/>
-              <a:t>9/15/2025</a:t>
+              <a:t>11/19/2025</a:t>
             </a:fld>
             <a:endParaRPr lang="en-US"/>
           </a:p>
@@ -12986,7 +12986,7 @@
           <a:p>
             <a:fld id="{710AE426-CBD1-49BA-A1DA-945CCEE2ED80}" type="datetimeFigureOut">
               <a:rPr lang="en-US" smtClean="0"/>
-              <a:t>9/15/2025</a:t>
+              <a:t>11/19/2025</a:t>
             </a:fld>
             <a:endParaRPr lang="en-US"/>
           </a:p>
@@ -13180,7 +13180,7 @@
           <a:p>
             <a:fld id="{710AE426-CBD1-49BA-A1DA-945CCEE2ED80}" type="datetimeFigureOut">
               <a:rPr lang="en-US" smtClean="0"/>
-              <a:t>9/15/2025</a:t>
+              <a:t>11/19/2025</a:t>
             </a:fld>
             <a:endParaRPr lang="en-US"/>
           </a:p>
@@ -13416,7 +13416,7 @@
           <a:p>
             <a:fld id="{710AE426-CBD1-49BA-A1DA-945CCEE2ED80}" type="datetimeFigureOut">
               <a:rPr lang="en-US" smtClean="0"/>
-              <a:t>9/15/2025</a:t>
+              <a:t>11/19/2025</a:t>
             </a:fld>
             <a:endParaRPr lang="en-US"/>
           </a:p>
@@ -13696,7 +13696,7 @@
           <a:p>
             <a:fld id="{710AE426-CBD1-49BA-A1DA-945CCEE2ED80}" type="datetimeFigureOut">
               <a:rPr lang="en-US" smtClean="0"/>
-              <a:t>9/15/2025</a:t>
+              <a:t>11/19/2025</a:t>
             </a:fld>
             <a:endParaRPr lang="en-US"/>
           </a:p>
@@ -13939,7 +13939,7 @@
           <a:p>
             <a:fld id="{710AE426-CBD1-49BA-A1DA-945CCEE2ED80}" type="datetimeFigureOut">
               <a:rPr lang="en-US" smtClean="0"/>
-              <a:t>9/15/2025</a:t>
+              <a:t>11/19/2025</a:t>
             </a:fld>
             <a:endParaRPr lang="en-US"/>
           </a:p>
@@ -14387,7 +14387,7 @@
           <a:p>
             <a:fld id="{710AE426-CBD1-49BA-A1DA-945CCEE2ED80}" type="datetimeFigureOut">
               <a:rPr lang="en-US" smtClean="0"/>
-              <a:t>9/15/2025</a:t>
+              <a:t>11/19/2025</a:t>
             </a:fld>
             <a:endParaRPr lang="en-US"/>
           </a:p>
@@ -14541,7 +14541,7 @@
           <a:p>
             <a:fld id="{710AE426-CBD1-49BA-A1DA-945CCEE2ED80}" type="datetimeFigureOut">
               <a:rPr lang="en-US" smtClean="0"/>
-              <a:t>9/15/2025</a:t>
+              <a:t>11/19/2025</a:t>
             </a:fld>
             <a:endParaRPr lang="en-US"/>
           </a:p>
@@ -14654,7 +14654,7 @@
           <a:p>
             <a:fld id="{710AE426-CBD1-49BA-A1DA-945CCEE2ED80}" type="datetimeFigureOut">
               <a:rPr lang="en-US" smtClean="0"/>
-              <a:t>9/15/2025</a:t>
+              <a:t>11/19/2025</a:t>
             </a:fld>
             <a:endParaRPr lang="en-US"/>
           </a:p>
@@ -14962,7 +14962,7 @@
           <a:p>
             <a:fld id="{710AE426-CBD1-49BA-A1DA-945CCEE2ED80}" type="datetimeFigureOut">
               <a:rPr lang="en-US" smtClean="0"/>
-              <a:t>9/15/2025</a:t>
+              <a:t>11/19/2025</a:t>
             </a:fld>
             <a:endParaRPr lang="en-US"/>
           </a:p>
@@ -15268,7 +15268,7 @@
           <a:p>
             <a:fld id="{710AE426-CBD1-49BA-A1DA-945CCEE2ED80}" type="datetimeFigureOut">
               <a:rPr lang="en-US" smtClean="0"/>
-              <a:t>9/15/2025</a:t>
+              <a:t>11/19/2025</a:t>
             </a:fld>
             <a:endParaRPr lang="en-US"/>
           </a:p>
@@ -15510,7 +15510,7 @@
           <a:p>
             <a:fld id="{710AE426-CBD1-49BA-A1DA-945CCEE2ED80}" type="datetimeFigureOut">
               <a:rPr lang="en-US" smtClean="0"/>
-              <a:t>9/15/2025</a:t>
+              <a:t>11/19/2025</a:t>
             </a:fld>
             <a:endParaRPr lang="en-US"/>
           </a:p>
@@ -15754,7 +15754,7 @@
           <a:p>
             <a:fld id="{710AE426-CBD1-49BA-A1DA-945CCEE2ED80}" type="datetimeFigureOut">
               <a:rPr lang="en-US" smtClean="0"/>
-              <a:t>9/15/2025</a:t>
+              <a:t>11/19/2025</a:t>
             </a:fld>
             <a:endParaRPr lang="en-US"/>
           </a:p>
@@ -15950,7 +15950,7 @@
           <a:p>
             <a:fld id="{710AE426-CBD1-49BA-A1DA-945CCEE2ED80}" type="datetimeFigureOut">
               <a:rPr lang="en-US" smtClean="0"/>
-              <a:t>9/15/2025</a:t>
+              <a:t>11/19/2025</a:t>
             </a:fld>
             <a:endParaRPr lang="en-US"/>
           </a:p>
@@ -16172,7 +16172,7 @@
           <a:p>
             <a:fld id="{710AE426-CBD1-49BA-A1DA-945CCEE2ED80}" type="datetimeFigureOut">
               <a:rPr lang="en-US" smtClean="0"/>
-              <a:t>9/15/2025</a:t>
+              <a:t>11/19/2025</a:t>
             </a:fld>
             <a:endParaRPr lang="en-US"/>
           </a:p>
@@ -16389,7 +16389,7 @@
           <a:p>
             <a:fld id="{710AE426-CBD1-49BA-A1DA-945CCEE2ED80}" type="datetimeFigureOut">
               <a:rPr lang="en-US" smtClean="0"/>
-              <a:t>9/15/2025</a:t>
+              <a:t>11/19/2025</a:t>
             </a:fld>
             <a:endParaRPr lang="en-US"/>
           </a:p>
@@ -16631,7 +16631,7 @@
           <a:p>
             <a:fld id="{710AE426-CBD1-49BA-A1DA-945CCEE2ED80}" type="datetimeFigureOut">
               <a:rPr lang="en-US" smtClean="0"/>
-              <a:t>9/15/2025</a:t>
+              <a:t>11/19/2025</a:t>
             </a:fld>
             <a:endParaRPr lang="en-US"/>
           </a:p>
@@ -16904,7 +16904,7 @@
           <a:p>
             <a:fld id="{710AE426-CBD1-49BA-A1DA-945CCEE2ED80}" type="datetimeFigureOut">
               <a:rPr lang="en-US" smtClean="0"/>
-              <a:t>9/15/2025</a:t>
+              <a:t>11/19/2025</a:t>
             </a:fld>
             <a:endParaRPr lang="en-US"/>
           </a:p>
@@ -17410,10 +17410,7 @@
           </a:bodyPr>
           <a:lstStyle/>
           <a:p>
-            <a:r>
-              <a:rPr lang="en-US"/>
-              <a:t>Exploring collaboration through practical building challenges</a:t>
-            </a:r>
+            <a:endParaRPr lang="en-US" dirty="0"/>
           </a:p>
         </p:txBody>
       </p:sp>
@@ -17489,10 +17486,15 @@
                                 </p:cTn>
                               </p:par>
                               <p:par>
-                                <p:cTn id="8" presetID="10" presetClass="entr" presetSubtype="0" fill="hold" grpId="0" nodeType="withEffect">
+                                <p:cTn id="8" presetID="10" presetClass="entr" presetSubtype="0" fill="hold" grpId="0" nodeType="withEffect" nodePh="1">
                                   <p:stCondLst>
                                     <p:cond delay="1000"/>
                                   </p:stCondLst>
+                                  <p:endCondLst>
+                                    <p:cond evt="begin" delay="0">
+                                      <p:tn val="8"/>
+                                    </p:cond>
+                                  </p:endCondLst>
                                   <p:iterate>
                                     <p:tmPct val="10000"/>
                                   </p:iterate>
@@ -17535,10 +17537,15 @@
                                 </p:cTn>
                               </p:par>
                               <p:par>
-                                <p:cTn id="11" presetID="10" presetClass="entr" presetSubtype="0" fill="hold" grpId="1" nodeType="withEffect">
+                                <p:cTn id="11" presetID="10" presetClass="entr" presetSubtype="0" fill="hold" grpId="1" nodeType="withEffect" nodePh="1">
                                   <p:stCondLst>
                                     <p:cond delay="250"/>
                                   </p:stCondLst>
+                                  <p:endCondLst>
+                                    <p:cond evt="begin" delay="0">
+                                      <p:tn val="11"/>
+                                    </p:cond>
+                                  </p:endCondLst>
                                   <p:iterate>
                                     <p:tmPct val="10000"/>
                                   </p:iterate>
@@ -18340,16 +18347,14 @@
       </p:sp>
       <p:pic>
         <p:nvPicPr>
-          <p:cNvPr id="10" name="Picture 9">
-            <a:extLst>
-              <a:ext uri="{FF2B5EF4-FFF2-40B4-BE49-F238E27FC236}">
-                <a16:creationId xmlns:a16="http://schemas.microsoft.com/office/drawing/2014/main" id="{7D5C5A12-624A-1ECE-1E5F-FD6EE053ED30}"/>
-              </a:ext>
-            </a:extLst>
-          </p:cNvPr>
-          <p:cNvPicPr>
-            <a:picLocks noChangeAspect="1"/>
-          </p:cNvPicPr>
+          <p:cNvPr id="7" name="Picture">
+            <a:extLst>
+              <a:ext uri="{FF2B5EF4-FFF2-40B4-BE49-F238E27FC236}">
+                <a16:creationId xmlns:a16="http://schemas.microsoft.com/office/drawing/2014/main" id="{7EEA8CDE-0861-BF1D-912B-B4A3F3F47C32}"/>
+              </a:ext>
+            </a:extLst>
+          </p:cNvPr>
+          <p:cNvPicPr/>
           <p:nvPr/>
         </p:nvPicPr>
         <p:blipFill>
@@ -18358,15 +18363,54 @@
             <a:fillRect/>
           </a:stretch>
         </p:blipFill>
-        <p:spPr>
-          <a:xfrm>
-            <a:off x="2437500" y="1709862"/>
-            <a:ext cx="7313949" cy="4513752"/>
+        <p:spPr bwMode="auto">
+          <a:xfrm>
+            <a:off x="533400" y="1752600"/>
+            <a:ext cx="4057650" cy="3246120"/>
           </a:xfrm>
           <a:prstGeom prst="rect">
             <a:avLst/>
           </a:prstGeom>
           <a:noFill/>
+          <a:ln w="9525">
+            <a:noFill/>
+            <a:headEnd/>
+            <a:tailEnd/>
+          </a:ln>
+        </p:spPr>
+      </p:pic>
+      <p:pic>
+        <p:nvPicPr>
+          <p:cNvPr id="8" name="Picture">
+            <a:extLst>
+              <a:ext uri="{FF2B5EF4-FFF2-40B4-BE49-F238E27FC236}">
+                <a16:creationId xmlns:a16="http://schemas.microsoft.com/office/drawing/2014/main" id="{5CFBF3D6-6871-DDF8-6879-C9CCC8E066D6}"/>
+              </a:ext>
+            </a:extLst>
+          </p:cNvPr>
+          <p:cNvPicPr/>
+          <p:nvPr/>
+        </p:nvPicPr>
+        <p:blipFill>
+          <a:blip r:embed="rId4"/>
+          <a:stretch>
+            <a:fillRect/>
+          </a:stretch>
+        </p:blipFill>
+        <p:spPr bwMode="auto">
+          <a:xfrm>
+            <a:off x="5715000" y="1752600"/>
+            <a:ext cx="4057650" cy="3246120"/>
+          </a:xfrm>
+          <a:prstGeom prst="rect">
+            <a:avLst/>
+          </a:prstGeom>
+          <a:noFill/>
+          <a:ln w="9525">
+            <a:noFill/>
+            <a:headEnd/>
+            <a:tailEnd/>
+          </a:ln>
         </p:spPr>
       </p:pic>
     </p:spTree>
@@ -22096,6 +22140,15 @@
 </file>
 
 <file path=customXml/item1.xml><?xml version="1.0" encoding="utf-8"?>
+<?mso-contentType ?>
+<FormTemplates xmlns="http://schemas.microsoft.com/sharepoint/v3/contenttype/forms">
+  <Display>DocumentLibraryForm</Display>
+  <Edit>DocumentLibraryForm</Edit>
+  <New>DocumentLibraryForm</New>
+</FormTemplates>
+</file>
+
+<file path=customXml/item2.xml><?xml version="1.0" encoding="utf-8"?>
 <p:properties xmlns:p="http://schemas.microsoft.com/office/2006/metadata/properties" xmlns:xsi="http://www.w3.org/2001/XMLSchema-instance" xmlns:pc="http://schemas.microsoft.com/office/infopath/2007/PartnerControls">
   <documentManagement>
     <_ip_UnifiedCompliancePolicyUIAction xmlns="http://schemas.microsoft.com/sharepoint/v3" xsi:nil="true"/>
@@ -22113,15 +22166,6 @@
     <MediaServiceKeyPoints xmlns="71af3243-3dd4-4a8d-8c0d-dd76da1f02a5" xsi:nil="true"/>
   </documentManagement>
 </p:properties>
-</file>
-
-<file path=customXml/item2.xml><?xml version="1.0" encoding="utf-8"?>
-<?mso-contentType ?>
-<FormTemplates xmlns="http://schemas.microsoft.com/sharepoint/v3/contenttype/forms">
-  <Display>DocumentLibraryForm</Display>
-  <Edit>DocumentLibraryForm</Edit>
-  <New>DocumentLibraryForm</New>
-</FormTemplates>
 </file>
 
 <file path=customXml/item3.xml><?xml version="1.0" encoding="utf-8"?>
@@ -22443,6 +22487,14 @@
 </file>
 
 <file path=customXml/itemProps1.xml><?xml version="1.0" encoding="utf-8"?>
+<ds:datastoreItem xmlns:ds="http://schemas.openxmlformats.org/officeDocument/2006/customXml" ds:itemID="{43B79205-1ECA-438E-AAC0-B28ABB0DD1EB}">
+  <ds:schemaRefs>
+    <ds:schemaRef ds:uri="http://schemas.microsoft.com/sharepoint/v3/contenttype/forms"/>
+  </ds:schemaRefs>
+</ds:datastoreItem>
+</file>
+
+<file path=customXml/itemProps2.xml><?xml version="1.0" encoding="utf-8"?>
 <ds:datastoreItem xmlns:ds="http://schemas.openxmlformats.org/officeDocument/2006/customXml" ds:itemID="{3C0CEB72-9B64-43A4-9652-F0FED519FBF8}">
   <ds:schemaRefs>
     <ds:schemaRef ds:uri="http://schemas.microsoft.com/office/2006/metadata/properties"/>
@@ -22450,14 +22502,6 @@
     <ds:schemaRef ds:uri="http://schemas.microsoft.com/sharepoint/v3"/>
     <ds:schemaRef ds:uri="71af3243-3dd4-4a8d-8c0d-dd76da1f02a5"/>
     <ds:schemaRef ds:uri="230e9df3-be65-4c73-a93b-d1236ebd677e"/>
-  </ds:schemaRefs>
-</ds:datastoreItem>
-</file>
-
-<file path=customXml/itemProps2.xml><?xml version="1.0" encoding="utf-8"?>
-<ds:datastoreItem xmlns:ds="http://schemas.openxmlformats.org/officeDocument/2006/customXml" ds:itemID="{43B79205-1ECA-438E-AAC0-B28ABB0DD1EB}">
-  <ds:schemaRefs>
-    <ds:schemaRef ds:uri="http://schemas.microsoft.com/sharepoint/v3/contenttype/forms"/>
   </ds:schemaRefs>
 </ds:datastoreItem>
 </file>

</xml_diff>